<commit_message>
Strengthen deep learning calculation demos
</commit_message>
<xml_diff>
--- a/02_activation_functions/excel_activation_functions_slides.pptx
+++ b/02_activation_functions/excel_activation_functions_slides.pptx
@@ -3278,16 +3278,8 @@
           </a:bodyPr>
           <a:lstStyle/>
           <a:p>
-            <a:pPr algn="l">
-              <a:defRPr sz="1500" b="1">
-                <a:solidFill>
-                  <a:srgbClr val="475569"/>
-                </a:solidFill>
-                <a:latin typeface="Yu Gothic"/>
-              </a:defRPr>
-            </a:pPr>
-            <a:r>
-              <a:t>入力値を変えると、出力と勾配が変わることを見る</a:t>
+            <a:r>
+              <a:t>活性化関数の出力と勾配のつながりを見る</a:t>
             </a:r>
           </a:p>
         </p:txBody>
@@ -4979,24 +4971,16 @@
           <a:bodyPr rtlCol="0" anchor="ctr" wrap="square" bIns="36576"/>
           <a:lstStyle/>
           <a:p>
-            <a:pPr algn="ctr">
-              <a:defRPr sz="1700" b="1">
-                <a:solidFill>
-                  <a:srgbClr val="276749"/>
-                </a:solidFill>
-                <a:latin typeface="Yu Gothic"/>
-              </a:defRPr>
-            </a:pPr>
-            <a:r>
-              <a:t>まずは</a:t>
+            <a:r>
+              <a:t>activationから</a:t>
             </a:r>
             <a:br/>
             <a:r>
-              <a:t>基本の表</a:t>
+              <a:t>softmax_ce_gradへ</a:t>
             </a:r>
             <a:br/>
             <a:r>
-              <a:t>から読む</a:t>
+              <a:t>つなげて読む</a:t>
             </a:r>
           </a:p>
         </p:txBody>
@@ -5452,20 +5436,12 @@
           <a:bodyPr rtlCol="0" anchor="ctr" wrap="square" bIns="36576"/>
           <a:lstStyle/>
           <a:p>
-            <a:pPr algn="ctr">
-              <a:defRPr sz="1700" b="1">
-                <a:solidFill>
-                  <a:srgbClr val="2F6690"/>
-                </a:solidFill>
-                <a:latin typeface="Yu Gothic"/>
-              </a:defRPr>
-            </a:pPr>
-            <a:r>
-              <a:t>列名を</a:t>
+            <a:r>
+              <a:t>probability、target、</a:t>
             </a:r>
             <a:br/>
             <a:r>
-              <a:t>計算の役割に</a:t>
+              <a:t>dLoss_dlogitを</a:t>
             </a:r>
             <a:br/>
             <a:r>
@@ -5925,24 +5901,16 @@
           <a:bodyPr rtlCol="0" anchor="ctr" wrap="square" bIns="36576"/>
           <a:lstStyle/>
           <a:p>
-            <a:pPr algn="ctr">
-              <a:defRPr sz="1700" b="1">
-                <a:solidFill>
-                  <a:srgbClr val="276749"/>
-                </a:solidFill>
-                <a:latin typeface="Yu Gothic"/>
-              </a:defRPr>
-            </a:pPr>
-            <a:r>
-              <a:t>設定を変えたら</a:t>
+            <a:r>
+              <a:t>target_classを</a:t>
             </a:r>
             <a:br/>
             <a:r>
-              <a:t>どの列が動くかを</a:t>
+              <a:t>変えたら</a:t>
             </a:r>
             <a:br/>
             <a:r>
-              <a:t>見る</a:t>
+              <a:t>p-yの列を見る</a:t>
             </a:r>
           </a:p>
         </p:txBody>
@@ -6627,16 +6595,8 @@
           <a:bodyPr rtlCol="0" anchor="ctr" wrap="square" bIns="36576"/>
           <a:lstStyle/>
           <a:p>
-            <a:pPr algn="ctr">
-              <a:defRPr sz="1400" b="1">
-                <a:solidFill>
-                  <a:srgbClr val="24324B"/>
-                </a:solidFill>
-                <a:latin typeface="Yu Gothic"/>
-              </a:defRPr>
-            </a:pPr>
-            <a:r>
-              <a:t>第3回で予測と正解のズレを見る</a:t>
+            <a:r>
+              <a:t>第3回でCross EntropyのLossを見る</a:t>
             </a:r>
           </a:p>
         </p:txBody>
@@ -7042,16 +7002,8 @@
           <a:bodyPr rtlCol="0" anchor="ctr" wrap="square" bIns="36576"/>
           <a:lstStyle/>
           <a:p>
-            <a:pPr algn="ctr">
-              <a:defRPr sz="1600" b="1">
-                <a:solidFill>
-                  <a:srgbClr val="24324B"/>
-                </a:solidFill>
-                <a:latin typeface="Yu Gothic"/>
-              </a:defRPr>
-            </a:pPr>
-            <a:r>
-              <a:t>小さくしているのは、式と表の対応を見失わないためです。</a:t>
+            <a:r>
+              <a:t>この回では1つのSoftmax表で、出力確率とp-yの対応に絞ります。</a:t>
             </a:r>
           </a:p>
         </p:txBody>
@@ -7389,16 +7341,8 @@
           </a:bodyPr>
           <a:lstStyle/>
           <a:p>
-            <a:pPr algn="ctr">
-              <a:defRPr sz="1800" b="1">
-                <a:solidFill>
-                  <a:srgbClr val="24324B"/>
-                </a:solidFill>
-                <a:latin typeface="Yu Gothic"/>
-              </a:defRPr>
-            </a:pPr>
-            <a:r>
-              <a:t>入力値を変えると、出力と勾配が変わることを見る</a:t>
+            <a:r>
+              <a:t>活性化関数の出力と勾配のつながりを見る</a:t>
             </a:r>
           </a:p>
         </p:txBody>
@@ -7523,16 +7467,33 @@
           </a:bodyPr>
           <a:lstStyle/>
           <a:p>
-            <a:pPr algn="l">
-              <a:defRPr sz="2500" b="1">
-                <a:solidFill>
-                  <a:srgbClr val="24324B"/>
-                </a:solidFill>
-                <a:latin typeface="Yu Gothic"/>
-              </a:defRPr>
-            </a:pPr>
             <a:r>
               <a:t>この回の用語</a:t>
+            </a:r>
+          </a:p>
+          <a:p>
+            <a:r>
+              <a:t>Sigmoid: 0から1へ押し込む関数</a:t>
+            </a:r>
+          </a:p>
+          <a:p>
+            <a:r>
+              <a:t>tanh: -1から1へ押し込む関数</a:t>
+            </a:r>
+          </a:p>
+          <a:p>
+            <a:r>
+              <a:t>ReLU: 0以下を0にする関数</a:t>
+            </a:r>
+          </a:p>
+          <a:p>
+            <a:r>
+              <a:t>Softmax: logitを合計1の確率にする関数</a:t>
+            </a:r>
+          </a:p>
+          <a:p>
+            <a:r>
+              <a:t>p-y: SoftmaxとCross Entropyを合わせた勾配</a:t>
             </a:r>
           </a:p>
         </p:txBody>
@@ -8678,16 +8639,8 @@
           <a:bodyPr rtlCol="0" anchor="ctr" wrap="square" bIns="36576"/>
           <a:lstStyle/>
           <a:p>
-            <a:pPr algn="ctr">
-              <a:defRPr sz="1400" b="1">
-                <a:solidFill>
-                  <a:srgbClr val="24324B"/>
-                </a:solidFill>
-                <a:latin typeface="Yu Gothic"/>
-              </a:defRPr>
-            </a:pPr>
-            <a:r>
-              <a:t>scoreに非線形な曲がりを加える</a:t>
+            <a:r>
+              <a:t>scoreを出力や勾配へ変える</a:t>
             </a:r>
           </a:p>
         </p:txBody>
@@ -8812,16 +8765,8 @@
           </a:bodyPr>
           <a:lstStyle/>
           <a:p>
-            <a:pPr algn="l">
-              <a:defRPr sz="2500" b="1">
-                <a:solidFill>
-                  <a:srgbClr val="24324B"/>
-                </a:solidFill>
-                <a:latin typeface="Yu Gothic"/>
-              </a:defRPr>
-            </a:pPr>
-            <a:r>
-              <a:t>入力値を変えると、出力と勾配が変わることを見る</a:t>
+            <a:r>
+              <a:t>活性化関数の出力と勾配のつながりを見る</a:t>
             </a:r>
           </a:p>
         </p:txBody>
@@ -8848,65 +8793,21 @@
           </a:bodyPr>
           <a:lstStyle/>
           <a:p>
-            <a:pPr>
-              <a:spcAft>
-                <a:spcPts val="800"/>
-              </a:spcAft>
-              <a:defRPr sz="1600">
-                <a:solidFill>
-                  <a:srgbClr val="24324B"/>
-                </a:solidFill>
-                <a:latin typeface="Yu Gothic"/>
-              </a:defRPr>
-            </a:pPr>
-            <a:r>
-              <a:t>• 入力値を変えると、出力と勾配が変わることを見る</a:t>
-            </a:r>
-          </a:p>
-          <a:p>
-            <a:pPr>
-              <a:spcAft>
-                <a:spcPts val="800"/>
-              </a:spcAft>
-              <a:defRPr sz="1600">
-                <a:solidFill>
-                  <a:srgbClr val="24324B"/>
-                </a:solidFill>
-                <a:latin typeface="Yu Gothic"/>
-              </a:defRPr>
-            </a:pPr>
+            <a:r>
+              <a:t>• 活性化関数の出力と勾配のつながりを見る</a:t>
+            </a:r>
+          </a:p>
+          <a:p>
             <a:r>
               <a:t>• Excel上の値や設定を変更する</a:t>
             </a:r>
           </a:p>
           <a:p>
-            <a:pPr>
-              <a:spcAft>
-                <a:spcPts val="800"/>
-              </a:spcAft>
-              <a:defRPr sz="1600">
-                <a:solidFill>
-                  <a:srgbClr val="24324B"/>
-                </a:solidFill>
-                <a:latin typeface="Yu Gothic"/>
-              </a:defRPr>
-            </a:pPr>
             <a:r>
               <a:t>• PythonがWorkbookから読み直して計算する</a:t>
             </a:r>
           </a:p>
           <a:p>
-            <a:pPr>
-              <a:spcAft>
-                <a:spcPts val="800"/>
-              </a:spcAft>
-              <a:defRPr sz="1600">
-                <a:solidFill>
-                  <a:srgbClr val="24324B"/>
-                </a:solidFill>
-                <a:latin typeface="Yu Gothic"/>
-              </a:defRPr>
-            </a:pPr>
             <a:r>
               <a:t>• 返却表の列を見て変化を確認する</a:t>
             </a:r>
@@ -8954,21 +8855,13 @@
           <a:bodyPr rtlCol="0" anchor="ctr" wrap="square" bIns="36576"/>
           <a:lstStyle/>
           <a:p>
-            <a:pPr algn="ctr">
-              <a:defRPr sz="1100" b="1">
-                <a:solidFill>
-                  <a:srgbClr val="2F6690"/>
-                </a:solidFill>
-                <a:latin typeface="Yu Gothic"/>
-              </a:defRPr>
-            </a:pPr>
             <a:r>
               <a:t>活性化関数とは</a:t>
             </a:r>
             <a:br/>
             <a:br/>
             <a:r>
-              <a:t>活性化関数とは、線形変換で作ったscoreを別の形に変換し、ニューラルネットワークに非線形な表現力を加える関数です。</a:t>
+              <a:t>活性化関数とは、線形変換で作ったscoreを別の形に変換し、ニューラルネットワークに非線形な表現力を加える関数です。Softmaxは分類の確率として読み、Cross Entropyの勾配へつながります。</a:t>
             </a:r>
           </a:p>
         </p:txBody>
@@ -9014,25 +8907,17 @@
           <a:bodyPr rtlCol="0" anchor="ctr" wrap="square" bIns="36576"/>
           <a:lstStyle/>
           <a:p>
-            <a:pPr algn="ctr">
-              <a:defRPr sz="1500" b="1">
-                <a:solidFill>
-                  <a:srgbClr val="276749"/>
-                </a:solidFill>
-                <a:latin typeface="Yu Gothic"/>
-              </a:defRPr>
-            </a:pPr>
             <a:r>
               <a:t>見える変化</a:t>
             </a:r>
             <a:br/>
             <a:br/>
             <a:r>
-              <a:t>input_value</a:t>
+              <a:t>target_class</a:t>
             </a:r>
             <a:br/>
             <a:r>
-              <a:t>出力と勾配</a:t>
+              <a:t>p-yの勾配</a:t>
             </a:r>
           </a:p>
         </p:txBody>
@@ -10390,16 +10275,8 @@
           <a:bodyPr rtlCol="0" anchor="ctr" wrap="square" bIns="36576"/>
           <a:lstStyle/>
           <a:p>
-            <a:pPr algn="ctr">
-              <a:defRPr sz="1500" b="1">
-                <a:solidFill>
-                  <a:srgbClr val="276749"/>
-                </a:solidFill>
-                <a:latin typeface="Yu Gothic"/>
-              </a:defRPr>
-            </a:pPr>
-            <a:r>
-              <a:t>scoreに非線形な曲がりを加える</a:t>
+            <a:r>
+              <a:t>scoreを出力や勾配へ変える</a:t>
             </a:r>
           </a:p>
         </p:txBody>
@@ -10445,16 +10322,8 @@
           <a:bodyPr rtlCol="0" anchor="ctr" wrap="square" bIns="36576"/>
           <a:lstStyle/>
           <a:p>
-            <a:pPr algn="ctr">
-              <a:defRPr sz="1400" b="1">
-                <a:solidFill>
-                  <a:srgbClr val="276749"/>
-                </a:solidFill>
-                <a:latin typeface="Yu Gothic"/>
-              </a:defRPr>
-            </a:pPr>
-            <a:r>
-              <a:t>scoreに非線形な曲がりを加える</a:t>
+            <a:r>
+              <a:t>scoreを出力や勾配へ変える</a:t>
             </a:r>
           </a:p>
         </p:txBody>
@@ -11620,16 +11489,8 @@
           <a:bodyPr rtlCol="0" anchor="ctr" wrap="square" bIns="36576"/>
           <a:lstStyle/>
           <a:p>
-            <a:pPr algn="ctr">
-              <a:defRPr sz="1500" b="1">
-                <a:solidFill>
-                  <a:srgbClr val="24324B"/>
-                </a:solidFill>
-                <a:latin typeface="Yu Gothic"/>
-              </a:defRPr>
-            </a:pPr>
-            <a:r>
-              <a:t>Excelで変更した値が、そのままPythonの計算結果に反映されます。</a:t>
+            <a:r>
+              <a:t>logitやtarget_classを変えると、Softmaxの確率とp-yの勾配が変わります。</a:t>
             </a:r>
           </a:p>
         </p:txBody>
@@ -11754,16 +11615,8 @@
           </a:bodyPr>
           <a:lstStyle/>
           <a:p>
-            <a:pPr algn="l">
-              <a:defRPr sz="2500" b="1">
-                <a:solidFill>
-                  <a:srgbClr val="24324B"/>
-                </a:solidFill>
-                <a:latin typeface="Yu Gothic"/>
-              </a:defRPr>
-            </a:pPr>
-            <a:r>
-              <a:t>どこを変えると、どの表が変わるか</a:t>
+            <a:r>
+              <a:t>どこを変えると、出力や勾配が変わるか</a:t>
             </a:r>
           </a:p>
         </p:txBody>
@@ -12132,16 +11985,8 @@
           <a:bodyPr rtlCol="0" anchor="ctr" wrap="square" bIns="36576"/>
           <a:lstStyle/>
           <a:p>
-            <a:pPr algn="ctr">
-              <a:defRPr sz="1500" b="1">
-                <a:solidFill>
-                  <a:srgbClr val="276749"/>
-                </a:solidFill>
-                <a:latin typeface="Yu Gothic"/>
-              </a:defRPr>
-            </a:pPr>
-            <a:r>
-              <a:t>操作の目的は、値を変えた時の表の変化を読むことです。</a:t>
+            <a:r>
+              <a:t>activation、softmax、softmax_ce_gradを切り替えて、出力から勾配への流れを読みます。</a:t>
             </a:r>
           </a:p>
         </p:txBody>
@@ -13442,20 +13287,12 @@
           <a:bodyPr rtlCol="0" anchor="ctr" wrap="square" bIns="36576"/>
           <a:lstStyle/>
           <a:p>
-            <a:pPr algn="ctr">
-              <a:defRPr sz="1800" b="1">
-                <a:solidFill>
-                  <a:srgbClr val="276749"/>
-                </a:solidFill>
-                <a:latin typeface="Yu Gothic"/>
-              </a:defRPr>
-            </a:pPr>
-            <a:r>
-              <a:t>初期値の</a:t>
+            <a:r>
+              <a:t>softmaxと</a:t>
             </a:r>
             <a:br/>
             <a:r>
-              <a:t>結果を読む</a:t>
+              <a:t>p-yを読む</a:t>
             </a:r>
           </a:p>
         </p:txBody>

</xml_diff>